<commit_message>
docs: add Sources & References slides to taxonomy deck
Add two References slides (37 slides total) listing the 10 research sources
as clickable hyperlinks: primary telc/BAMF/DeuFoeV framework + exam sources
and the CEFR standard, plus secondary Babbel benchmark articles. Include an
honesty note distinguishing cited claims from general product knowledge.
Mirror the full source list into the markdown addendum.

Co-Authored-By: Claude Opus 4.8 <noreply@anthropic.com>
Claude-Session: https://claude.ai/code/session_011ymX8ESwFUGNGYV7UJyyf3
</commit_message>
<xml_diff>
--- a/docs/TAXONOMY_REDESIGN.pptx
+++ b/docs/TAXONOMY_REDESIGN.pptx
@@ -40,6 +40,8 @@
     <p:sldId id="288" r:id="rId39"/>
     <p:sldId id="289" r:id="rId40"/>
     <p:sldId id="290" r:id="rId41"/>
+    <p:sldId id="291" r:id="rId42"/>
+    <p:sldId id="292" r:id="rId43"/>
   </p:sldIdLst>
   <p:sldSz cx="12191695" cy="6858000" type="screen4x3"/>
   <p:notesSz cx="6858000" cy="9144000"/>
@@ -23964,6 +23966,1393 @@
 </p:sld>
 </file>
 
+<file path=ppt/slides/slide36.xml><?xml version="1.0" encoding="utf-8"?>
+<p:sld xmlns:a="http://schemas.openxmlformats.org/drawingml/2006/main" xmlns:p="http://schemas.openxmlformats.org/presentationml/2006/main" xmlns:r="http://schemas.openxmlformats.org/officeDocument/2006/relationships">
+  <p:cSld>
+    <p:spTree>
+      <p:nvGrpSpPr>
+        <p:cNvPr id="1" name=""/>
+        <p:cNvGrpSpPr/>
+        <p:nvPr/>
+      </p:nvGrpSpPr>
+      <p:grpSpPr/>
+      <p:sp>
+        <p:nvSpPr>
+          <p:cNvPr id="2" name="Rectangle 1"/>
+          <p:cNvSpPr/>
+          <p:nvPr/>
+        </p:nvSpPr>
+        <p:spPr>
+          <a:xfrm>
+            <a:off x="0" y="0"/>
+            <a:ext cx="12191695" cy="6858000"/>
+          </a:xfrm>
+          <a:prstGeom prst="rect">
+            <a:avLst/>
+          </a:prstGeom>
+          <a:solidFill>
+            <a:srgbClr val="FFFFFF"/>
+          </a:solidFill>
+          <a:ln>
+            <a:noFill/>
+          </a:ln>
+          <a:effectLst/>
+        </p:spPr>
+        <p:style>
+          <a:lnRef idx="1">
+            <a:schemeClr val="accent1"/>
+          </a:lnRef>
+          <a:fillRef idx="3">
+            <a:schemeClr val="accent1"/>
+          </a:fillRef>
+          <a:effectRef idx="2">
+            <a:schemeClr val="accent1"/>
+          </a:effectRef>
+          <a:fontRef idx="minor">
+            <a:schemeClr val="lt1"/>
+          </a:fontRef>
+        </p:style>
+        <p:txBody>
+          <a:bodyPr rtlCol="0" anchor="ctr"/>
+          <a:lstStyle/>
+          <a:p>
+            <a:pPr algn="ctr"/>
+          </a:p>
+        </p:txBody>
+      </p:sp>
+      <p:sp>
+        <p:nvSpPr>
+          <p:cNvPr id="3" name="Rectangle 2"/>
+          <p:cNvSpPr/>
+          <p:nvPr/>
+        </p:nvSpPr>
+        <p:spPr>
+          <a:xfrm>
+            <a:off x="0" y="0"/>
+            <a:ext cx="164592" cy="6858000"/>
+          </a:xfrm>
+          <a:prstGeom prst="rect">
+            <a:avLst/>
+          </a:prstGeom>
+          <a:solidFill>
+            <a:srgbClr val="777488"/>
+          </a:solidFill>
+          <a:ln>
+            <a:noFill/>
+          </a:ln>
+          <a:effectLst/>
+        </p:spPr>
+        <p:style>
+          <a:lnRef idx="1">
+            <a:schemeClr val="accent1"/>
+          </a:lnRef>
+          <a:fillRef idx="3">
+            <a:schemeClr val="accent1"/>
+          </a:fillRef>
+          <a:effectRef idx="2">
+            <a:schemeClr val="accent1"/>
+          </a:effectRef>
+          <a:fontRef idx="minor">
+            <a:schemeClr val="lt1"/>
+          </a:fontRef>
+        </p:style>
+        <p:txBody>
+          <a:bodyPr rtlCol="0" anchor="ctr"/>
+          <a:lstStyle/>
+          <a:p>
+            <a:pPr algn="ctr"/>
+          </a:p>
+        </p:txBody>
+      </p:sp>
+      <p:sp>
+        <p:nvSpPr>
+          <p:cNvPr id="4" name="TextBox 3"/>
+          <p:cNvSpPr txBox="1"/>
+          <p:nvPr/>
+        </p:nvSpPr>
+        <p:spPr>
+          <a:xfrm>
+            <a:off x="502920" y="292608"/>
+            <a:ext cx="10424160" cy="365760"/>
+          </a:xfrm>
+          <a:prstGeom prst="rect">
+            <a:avLst/>
+          </a:prstGeom>
+          <a:noFill/>
+        </p:spPr>
+        <p:txBody>
+          <a:bodyPr wrap="square" anchor="t" lIns="45720" rIns="45720" tIns="18288" bIns="18288">
+            <a:spAutoFit/>
+          </a:bodyPr>
+          <a:lstStyle/>
+          <a:p>
+            <a:pPr algn="l">
+              <a:spcBef>
+                <a:spcPts val="0"/>
+              </a:spcBef>
+              <a:spcAft>
+                <a:spcPts val="200"/>
+              </a:spcAft>
+            </a:pPr>
+            <a:r>
+              <a:rPr sz="1200" b="1" i="0">
+                <a:solidFill>
+                  <a:srgbClr val="777488"/>
+                </a:solidFill>
+                <a:latin typeface="Calibri"/>
+              </a:rPr>
+              <a:t>REFERENCES</a:t>
+            </a:r>
+          </a:p>
+        </p:txBody>
+      </p:sp>
+      <p:sp>
+        <p:nvSpPr>
+          <p:cNvPr id="5" name="TextBox 4"/>
+          <p:cNvSpPr txBox="1"/>
+          <p:nvPr/>
+        </p:nvSpPr>
+        <p:spPr>
+          <a:xfrm>
+            <a:off x="502920" y="585216"/>
+            <a:ext cx="10881360" cy="868680"/>
+          </a:xfrm>
+          <a:prstGeom prst="rect">
+            <a:avLst/>
+          </a:prstGeom>
+          <a:noFill/>
+        </p:spPr>
+        <p:txBody>
+          <a:bodyPr wrap="square" anchor="t" lIns="45720" rIns="45720" tIns="18288" bIns="18288">
+            <a:spAutoFit/>
+          </a:bodyPr>
+          <a:lstStyle/>
+          <a:p>
+            <a:pPr algn="l">
+              <a:spcBef>
+                <a:spcPts val="0"/>
+              </a:spcBef>
+              <a:spcAft>
+                <a:spcPts val="0"/>
+              </a:spcAft>
+            </a:pPr>
+            <a:r>
+              <a:rPr sz="2600" b="1" i="0">
+                <a:solidFill>
+                  <a:srgbClr val="1E1B2E"/>
+                </a:solidFill>
+                <a:latin typeface="Calibri"/>
+              </a:rPr>
+              <a:t>Sources &amp; research</a:t>
+            </a:r>
+          </a:p>
+        </p:txBody>
+      </p:sp>
+      <p:sp>
+        <p:nvSpPr>
+          <p:cNvPr id="6" name="Rounded Rectangle 5"/>
+          <p:cNvSpPr/>
+          <p:nvPr/>
+        </p:nvSpPr>
+        <p:spPr>
+          <a:xfrm>
+            <a:off x="11338560" y="310896"/>
+            <a:ext cx="566928" cy="384048"/>
+          </a:xfrm>
+          <a:prstGeom prst="roundRect">
+            <a:avLst/>
+          </a:prstGeom>
+          <a:solidFill>
+            <a:srgbClr val="F4F3FA"/>
+          </a:solidFill>
+          <a:ln>
+            <a:noFill/>
+          </a:ln>
+          <a:effectLst/>
+        </p:spPr>
+        <p:style>
+          <a:lnRef idx="1">
+            <a:schemeClr val="accent1"/>
+          </a:lnRef>
+          <a:fillRef idx="3">
+            <a:schemeClr val="accent1"/>
+          </a:fillRef>
+          <a:effectRef idx="2">
+            <a:schemeClr val="accent1"/>
+          </a:effectRef>
+          <a:fontRef idx="minor">
+            <a:schemeClr val="lt1"/>
+          </a:fontRef>
+        </p:style>
+        <p:txBody>
+          <a:bodyPr rtlCol="0" anchor="ctr"/>
+          <a:lstStyle/>
+          <a:p>
+            <a:pPr algn="ctr"/>
+            <a:r>
+              <a:rPr sz="1200" b="1" i="0">
+                <a:solidFill>
+                  <a:srgbClr val="5B5BE6"/>
+                </a:solidFill>
+                <a:latin typeface="Calibri"/>
+              </a:rPr>
+              <a:t>33</a:t>
+            </a:r>
+          </a:p>
+        </p:txBody>
+      </p:sp>
+      <p:sp>
+        <p:nvSpPr>
+          <p:cNvPr id="7" name="Rectangle 6"/>
+          <p:cNvSpPr/>
+          <p:nvPr/>
+        </p:nvSpPr>
+        <p:spPr>
+          <a:xfrm>
+            <a:off x="502920" y="1335024"/>
+            <a:ext cx="1920240" cy="36576"/>
+          </a:xfrm>
+          <a:prstGeom prst="rect">
+            <a:avLst/>
+          </a:prstGeom>
+          <a:solidFill>
+            <a:srgbClr val="777488"/>
+          </a:solidFill>
+          <a:ln>
+            <a:noFill/>
+          </a:ln>
+          <a:effectLst/>
+        </p:spPr>
+        <p:style>
+          <a:lnRef idx="1">
+            <a:schemeClr val="accent1"/>
+          </a:lnRef>
+          <a:fillRef idx="3">
+            <a:schemeClr val="accent1"/>
+          </a:fillRef>
+          <a:effectRef idx="2">
+            <a:schemeClr val="accent1"/>
+          </a:effectRef>
+          <a:fontRef idx="minor">
+            <a:schemeClr val="lt1"/>
+          </a:fontRef>
+        </p:style>
+        <p:txBody>
+          <a:bodyPr rtlCol="0" anchor="ctr"/>
+          <a:lstStyle/>
+          <a:p>
+            <a:pPr algn="ctr"/>
+          </a:p>
+        </p:txBody>
+      </p:sp>
+      <p:sp>
+        <p:nvSpPr>
+          <p:cNvPr id="8" name="TextBox 7"/>
+          <p:cNvSpPr txBox="1"/>
+          <p:nvPr/>
+        </p:nvSpPr>
+        <p:spPr>
+          <a:xfrm>
+            <a:off x="548640" y="1572768"/>
+            <a:ext cx="5532120" cy="4846320"/>
+          </a:xfrm>
+          <a:prstGeom prst="rect">
+            <a:avLst/>
+          </a:prstGeom>
+          <a:noFill/>
+        </p:spPr>
+        <p:txBody>
+          <a:bodyPr wrap="square" anchor="t" lIns="45720" rIns="45720" tIns="18288" bIns="18288">
+            <a:spAutoFit/>
+          </a:bodyPr>
+          <a:lstStyle/>
+          <a:p>
+            <a:pPr algn="l">
+              <a:spcBef>
+                <a:spcPts val="0"/>
+              </a:spcBef>
+              <a:spcAft>
+                <a:spcPts val="800"/>
+              </a:spcAft>
+            </a:pPr>
+            <a:r>
+              <a:rPr sz="1200" b="1" i="0">
+                <a:solidFill>
+                  <a:srgbClr val="10B7CF"/>
+                </a:solidFill>
+                <a:latin typeface="Calibri"/>
+              </a:rPr>
+              <a:t>PRIMARY — German professional-language framework &amp; exams</a:t>
+            </a:r>
+          </a:p>
+          <a:p>
+            <a:pPr>
+              <a:spcBef>
+                <a:spcPts val="0"/>
+              </a:spcBef>
+              <a:spcAft>
+                <a:spcPts val="700"/>
+              </a:spcAft>
+            </a:pPr>
+            <a:r>
+              <a:rPr sz="1100" b="1" i="0">
+                <a:solidFill>
+                  <a:srgbClr val="777488"/>
+                </a:solidFill>
+                <a:latin typeface="Calibri"/>
+              </a:rPr>
+              <a:t>1  </a:t>
+            </a:r>
+            <a:r>
+              <a:rPr sz="1150" b="1" i="0">
+                <a:solidFill>
+                  <a:srgbClr val="1E1B2E"/>
+                </a:solidFill>
+                <a:latin typeface="Calibri"/>
+              </a:rPr>
+              <a:t>telc Deutsch B1·B2 Beruf — exam overview</a:t>
+            </a:r>
+          </a:p>
+          <a:p>
+            <a:pPr>
+              <a:spcBef>
+                <a:spcPts val="0"/>
+              </a:spcBef>
+              <a:spcAft>
+                <a:spcPts val="900"/>
+              </a:spcAft>
+            </a:pPr>
+            <a:r>
+              <a:rPr sz="1000" b="0" i="0">
+                <a:solidFill>
+                  <a:srgbClr val="777488"/>
+                </a:solidFill>
+                <a:latin typeface="Calibri"/>
+              </a:rPr>
+              <a:t>      </a:t>
+            </a:r>
+            <a:r>
+              <a:rPr sz="950" b="0" i="0" u="sng">
+                <a:solidFill>
+                  <a:srgbClr val="5B5BE6"/>
+                </a:solidFill>
+                <a:latin typeface="Calibri"/>
+                <a:hlinkClick r:id="rId2"/>
+              </a:rPr>
+              <a:t>https://www.telc.net/en/language-examinations/certificate-exams/german/telc-german-b1b2-business/</a:t>
+            </a:r>
+          </a:p>
+          <a:p>
+            <a:pPr>
+              <a:spcBef>
+                <a:spcPts val="0"/>
+              </a:spcBef>
+              <a:spcAft>
+                <a:spcPts val="700"/>
+              </a:spcAft>
+            </a:pPr>
+            <a:r>
+              <a:rPr sz="1100" b="1" i="0">
+                <a:solidFill>
+                  <a:srgbClr val="777488"/>
+                </a:solidFill>
+                <a:latin typeface="Calibri"/>
+              </a:rPr>
+              <a:t>2  </a:t>
+            </a:r>
+            <a:r>
+              <a:rPr sz="1150" b="1" i="0">
+                <a:solidFill>
+                  <a:srgbClr val="1E1B2E"/>
+                </a:solidFill>
+                <a:latin typeface="Calibri"/>
+              </a:rPr>
+              <a:t>telc Deutsch-Test für den Beruf B2</a:t>
+            </a:r>
+          </a:p>
+          <a:p>
+            <a:pPr>
+              <a:spcBef>
+                <a:spcPts val="0"/>
+              </a:spcBef>
+              <a:spcAft>
+                <a:spcPts val="900"/>
+              </a:spcAft>
+            </a:pPr>
+            <a:r>
+              <a:rPr sz="1000" b="0" i="0">
+                <a:solidFill>
+                  <a:srgbClr val="777488"/>
+                </a:solidFill>
+                <a:latin typeface="Calibri"/>
+              </a:rPr>
+              <a:t>      </a:t>
+            </a:r>
+            <a:r>
+              <a:rPr sz="950" b="0" i="0" u="sng">
+                <a:solidFill>
+                  <a:srgbClr val="5B5BE6"/>
+                </a:solidFill>
+                <a:latin typeface="Calibri"/>
+                <a:hlinkClick r:id="rId3"/>
+              </a:rPr>
+              <a:t>https://www.telc.net/en/language-examinations/certificate-exams/german/german-for-business/german-for-business-b2/</a:t>
+            </a:r>
+          </a:p>
+          <a:p>
+            <a:pPr>
+              <a:spcBef>
+                <a:spcPts val="0"/>
+              </a:spcBef>
+              <a:spcAft>
+                <a:spcPts val="700"/>
+              </a:spcAft>
+            </a:pPr>
+            <a:r>
+              <a:rPr sz="1100" b="1" i="0">
+                <a:solidFill>
+                  <a:srgbClr val="777488"/>
+                </a:solidFill>
+                <a:latin typeface="Calibri"/>
+              </a:rPr>
+              <a:t>3  </a:t>
+            </a:r>
+            <a:r>
+              <a:rPr sz="1150" b="1" i="0">
+                <a:solidFill>
+                  <a:srgbClr val="1E1B2E"/>
+                </a:solidFill>
+                <a:latin typeface="Calibri"/>
+              </a:rPr>
+              <a:t>telc Rahmencurriculum &amp; Handbuch Deutsch Pflege B1·B2 (PDF)</a:t>
+            </a:r>
+          </a:p>
+          <a:p>
+            <a:pPr>
+              <a:spcBef>
+                <a:spcPts val="0"/>
+              </a:spcBef>
+              <a:spcAft>
+                <a:spcPts val="900"/>
+              </a:spcAft>
+            </a:pPr>
+            <a:r>
+              <a:rPr sz="1000" b="0" i="0">
+                <a:solidFill>
+                  <a:srgbClr val="777488"/>
+                </a:solidFill>
+                <a:latin typeface="Calibri"/>
+              </a:rPr>
+              <a:t>      </a:t>
+            </a:r>
+            <a:r>
+              <a:rPr sz="950" b="0" i="0" u="sng">
+                <a:solidFill>
+                  <a:srgbClr val="5B5BE6"/>
+                </a:solidFill>
+                <a:latin typeface="Calibri"/>
+                <a:hlinkClick r:id="rId4"/>
+              </a:rPr>
+              <a:t>https://shop.telc.net/media/catalog/product/file/5036B01010201bib.pdf</a:t>
+            </a:r>
+          </a:p>
+          <a:p>
+            <a:pPr>
+              <a:spcBef>
+                <a:spcPts val="0"/>
+              </a:spcBef>
+              <a:spcAft>
+                <a:spcPts val="700"/>
+              </a:spcAft>
+            </a:pPr>
+            <a:r>
+              <a:rPr sz="1100" b="1" i="0">
+                <a:solidFill>
+                  <a:srgbClr val="777488"/>
+                </a:solidFill>
+                <a:latin typeface="Calibri"/>
+              </a:rPr>
+              <a:t>4  </a:t>
+            </a:r>
+            <a:r>
+              <a:rPr sz="1150" b="1" i="0">
+                <a:solidFill>
+                  <a:srgbClr val="1E1B2E"/>
+                </a:solidFill>
+                <a:latin typeface="Calibri"/>
+              </a:rPr>
+              <a:t>BAMF — Berufssprachkurse / DeuFöV (overview)</a:t>
+            </a:r>
+          </a:p>
+          <a:p>
+            <a:pPr>
+              <a:spcBef>
+                <a:spcPts val="0"/>
+              </a:spcBef>
+              <a:spcAft>
+                <a:spcPts val="900"/>
+              </a:spcAft>
+            </a:pPr>
+            <a:r>
+              <a:rPr sz="1000" b="0" i="0">
+                <a:solidFill>
+                  <a:srgbClr val="777488"/>
+                </a:solidFill>
+                <a:latin typeface="Calibri"/>
+              </a:rPr>
+              <a:t>      </a:t>
+            </a:r>
+            <a:r>
+              <a:rPr sz="950" b="0" i="0" u="sng">
+                <a:solidFill>
+                  <a:srgbClr val="5B5BE6"/>
+                </a:solidFill>
+                <a:latin typeface="Calibri"/>
+                <a:hlinkClick r:id="rId5"/>
+              </a:rPr>
+              <a:t>https://www.bamf.de/DE/Themen/Integration/ZugewanderteTeilnehmende/DeutschBeruf/deutsch-beruf.html</a:t>
+            </a:r>
+          </a:p>
+        </p:txBody>
+      </p:sp>
+      <p:sp>
+        <p:nvSpPr>
+          <p:cNvPr id="9" name="TextBox 8"/>
+          <p:cNvSpPr txBox="1"/>
+          <p:nvPr/>
+        </p:nvSpPr>
+        <p:spPr>
+          <a:xfrm>
+            <a:off x="6263640" y="1572768"/>
+            <a:ext cx="5486400" cy="4846320"/>
+          </a:xfrm>
+          <a:prstGeom prst="rect">
+            <a:avLst/>
+          </a:prstGeom>
+          <a:noFill/>
+        </p:spPr>
+        <p:txBody>
+          <a:bodyPr wrap="square" anchor="t" lIns="45720" rIns="45720" tIns="18288" bIns="18288">
+            <a:spAutoFit/>
+          </a:bodyPr>
+          <a:lstStyle/>
+          <a:p>
+            <a:pPr algn="l">
+              <a:spcBef>
+                <a:spcPts val="0"/>
+              </a:spcBef>
+              <a:spcAft>
+                <a:spcPts val="800"/>
+              </a:spcAft>
+            </a:pPr>
+            <a:r>
+              <a:rPr sz="1200" b="1" i="0">
+                <a:solidFill>
+                  <a:srgbClr val="10B7CF"/>
+                </a:solidFill>
+                <a:latin typeface="Calibri"/>
+              </a:rPr>
+              <a:t>PRIMARY (cont.) — sector &amp; curriculum detail</a:t>
+            </a:r>
+          </a:p>
+          <a:p>
+            <a:pPr>
+              <a:spcBef>
+                <a:spcPts val="0"/>
+              </a:spcBef>
+              <a:spcAft>
+                <a:spcPts val="700"/>
+              </a:spcAft>
+            </a:pPr>
+            <a:r>
+              <a:rPr sz="1100" b="1" i="0">
+                <a:solidFill>
+                  <a:srgbClr val="777488"/>
+                </a:solidFill>
+                <a:latin typeface="Calibri"/>
+              </a:rPr>
+              <a:t>5  </a:t>
+            </a:r>
+            <a:r>
+              <a:rPr sz="1150" b="1" i="0">
+                <a:solidFill>
+                  <a:srgbClr val="1E1B2E"/>
+                </a:solidFill>
+                <a:latin typeface="Calibri"/>
+              </a:rPr>
+              <a:t>BAMF — Berufssprachkurse Anerkennung Gesundheitswesen (Pflege)</a:t>
+            </a:r>
+          </a:p>
+          <a:p>
+            <a:pPr>
+              <a:spcBef>
+                <a:spcPts val="0"/>
+              </a:spcBef>
+              <a:spcAft>
+                <a:spcPts val="900"/>
+              </a:spcAft>
+            </a:pPr>
+            <a:r>
+              <a:rPr sz="1000" b="0" i="0">
+                <a:solidFill>
+                  <a:srgbClr val="777488"/>
+                </a:solidFill>
+                <a:latin typeface="Calibri"/>
+              </a:rPr>
+              <a:t>      </a:t>
+            </a:r>
+            <a:r>
+              <a:rPr sz="950" b="0" i="0" u="sng">
+                <a:solidFill>
+                  <a:srgbClr val="5B5BE6"/>
+                </a:solidFill>
+                <a:latin typeface="Calibri"/>
+                <a:hlinkClick r:id="rId6"/>
+              </a:rPr>
+              <a:t>https://www.bamf.de/DE/Themen/Integration/ZugewanderteTeilnehmende/AnerkennungsBSK/anerkennungsbsk-node.html</a:t>
+            </a:r>
+          </a:p>
+          <a:p>
+            <a:pPr>
+              <a:spcBef>
+                <a:spcPts val="0"/>
+              </a:spcBef>
+              <a:spcAft>
+                <a:spcPts val="700"/>
+              </a:spcAft>
+            </a:pPr>
+            <a:r>
+              <a:rPr sz="1100" b="1" i="0">
+                <a:solidFill>
+                  <a:srgbClr val="777488"/>
+                </a:solidFill>
+                <a:latin typeface="Calibri"/>
+              </a:rPr>
+              <a:t>6  </a:t>
+            </a:r>
+            <a:r>
+              <a:rPr sz="1150" b="1" i="0">
+                <a:solidFill>
+                  <a:srgbClr val="1E1B2E"/>
+                </a:solidFill>
+                <a:latin typeface="Calibri"/>
+              </a:rPr>
+              <a:t>BAMF — Konzept „Gesundheitsfachberufe“ (PDF)</a:t>
+            </a:r>
+          </a:p>
+          <a:p>
+            <a:pPr>
+              <a:spcBef>
+                <a:spcPts val="0"/>
+              </a:spcBef>
+              <a:spcAft>
+                <a:spcPts val="900"/>
+              </a:spcAft>
+            </a:pPr>
+            <a:r>
+              <a:rPr sz="1000" b="0" i="0">
+                <a:solidFill>
+                  <a:srgbClr val="777488"/>
+                </a:solidFill>
+                <a:latin typeface="Calibri"/>
+              </a:rPr>
+              <a:t>      </a:t>
+            </a:r>
+            <a:r>
+              <a:rPr sz="950" b="0" i="0" u="sng">
+                <a:solidFill>
+                  <a:srgbClr val="5B5BE6"/>
+                </a:solidFill>
+                <a:latin typeface="Calibri"/>
+                <a:hlinkClick r:id="rId7"/>
+              </a:rPr>
+              <a:t>https://www.bamf.de/SharedDocs/Anlagen/DE/Integration/Berufsbezsprachf-ESF-BAMF/BSK-Konzepte/konzept-nichtakademische-gesundheitsberufe.pdf</a:t>
+            </a:r>
+          </a:p>
+          <a:p>
+            <a:pPr>
+              <a:spcBef>
+                <a:spcPts val="0"/>
+              </a:spcBef>
+              <a:spcAft>
+                <a:spcPts val="700"/>
+              </a:spcAft>
+            </a:pPr>
+            <a:r>
+              <a:rPr sz="1100" b="1" i="0">
+                <a:solidFill>
+                  <a:srgbClr val="777488"/>
+                </a:solidFill>
+                <a:latin typeface="Calibri"/>
+              </a:rPr>
+              <a:t>7  </a:t>
+            </a:r>
+            <a:r>
+              <a:rPr sz="1150" b="1" i="0">
+                <a:solidFill>
+                  <a:srgbClr val="1E1B2E"/>
+                </a:solidFill>
+                <a:latin typeface="Calibri"/>
+              </a:rPr>
+              <a:t>BAMF — Lernzielkatalog Spezial-/Basisberufssprachkurse (PDF)</a:t>
+            </a:r>
+          </a:p>
+          <a:p>
+            <a:pPr>
+              <a:spcBef>
+                <a:spcPts val="0"/>
+              </a:spcBef>
+              <a:spcAft>
+                <a:spcPts val="900"/>
+              </a:spcAft>
+            </a:pPr>
+            <a:r>
+              <a:rPr sz="1000" b="0" i="0">
+                <a:solidFill>
+                  <a:srgbClr val="777488"/>
+                </a:solidFill>
+                <a:latin typeface="Calibri"/>
+              </a:rPr>
+              <a:t>      </a:t>
+            </a:r>
+            <a:r>
+              <a:rPr sz="950" b="0" i="0" u="sng">
+                <a:solidFill>
+                  <a:srgbClr val="5B5BE6"/>
+                </a:solidFill>
+                <a:latin typeface="Calibri"/>
+                <a:hlinkClick r:id="rId8"/>
+              </a:rPr>
+              <a:t>https://www.bamf.de/SharedDocs/Anlagen/DE/Integration/Berufsbezsprachf-ESF-BAMF/BSK-Konzepte/lernzielkatalog-spezial-und-basisberufssprachkurse.pdf</a:t>
+            </a:r>
+          </a:p>
+          <a:p>
+            <a:pPr>
+              <a:spcBef>
+                <a:spcPts val="0"/>
+              </a:spcBef>
+              <a:spcAft>
+                <a:spcPts val="700"/>
+              </a:spcAft>
+            </a:pPr>
+            <a:r>
+              <a:rPr sz="1100" b="1" i="0">
+                <a:solidFill>
+                  <a:srgbClr val="777488"/>
+                </a:solidFill>
+                <a:latin typeface="Calibri"/>
+              </a:rPr>
+              <a:t>8  </a:t>
+            </a:r>
+            <a:r>
+              <a:rPr sz="1150" b="1" i="0">
+                <a:solidFill>
+                  <a:srgbClr val="1E1B2E"/>
+                </a:solidFill>
+                <a:latin typeface="Calibri"/>
+              </a:rPr>
+              <a:t>Council of Europe — CEFR (official framework)</a:t>
+            </a:r>
+          </a:p>
+          <a:p>
+            <a:pPr>
+              <a:spcBef>
+                <a:spcPts val="0"/>
+              </a:spcBef>
+              <a:spcAft>
+                <a:spcPts val="900"/>
+              </a:spcAft>
+            </a:pPr>
+            <a:r>
+              <a:rPr sz="1000" b="0" i="0">
+                <a:solidFill>
+                  <a:srgbClr val="777488"/>
+                </a:solidFill>
+                <a:latin typeface="Calibri"/>
+              </a:rPr>
+              <a:t>      </a:t>
+            </a:r>
+            <a:r>
+              <a:rPr sz="950" b="0" i="0" u="sng">
+                <a:solidFill>
+                  <a:srgbClr val="5B5BE6"/>
+                </a:solidFill>
+                <a:latin typeface="Calibri"/>
+                <a:hlinkClick r:id="rId9"/>
+              </a:rPr>
+              <a:t>https://www.coe.int/en/web/common-european-framework-reference-languages</a:t>
+            </a:r>
+          </a:p>
+        </p:txBody>
+      </p:sp>
+    </p:spTree>
+  </p:cSld>
+  <p:clrMapOvr>
+    <a:masterClrMapping/>
+  </p:clrMapOvr>
+</p:sld>
+</file>
+
+<file path=ppt/slides/slide37.xml><?xml version="1.0" encoding="utf-8"?>
+<p:sld xmlns:a="http://schemas.openxmlformats.org/drawingml/2006/main" xmlns:p="http://schemas.openxmlformats.org/presentationml/2006/main" xmlns:r="http://schemas.openxmlformats.org/officeDocument/2006/relationships">
+  <p:cSld>
+    <p:spTree>
+      <p:nvGrpSpPr>
+        <p:cNvPr id="1" name=""/>
+        <p:cNvGrpSpPr/>
+        <p:nvPr/>
+      </p:nvGrpSpPr>
+      <p:grpSpPr/>
+      <p:sp>
+        <p:nvSpPr>
+          <p:cNvPr id="2" name="Rectangle 1"/>
+          <p:cNvSpPr/>
+          <p:nvPr/>
+        </p:nvSpPr>
+        <p:spPr>
+          <a:xfrm>
+            <a:off x="0" y="0"/>
+            <a:ext cx="12191695" cy="6858000"/>
+          </a:xfrm>
+          <a:prstGeom prst="rect">
+            <a:avLst/>
+          </a:prstGeom>
+          <a:solidFill>
+            <a:srgbClr val="FFFFFF"/>
+          </a:solidFill>
+          <a:ln>
+            <a:noFill/>
+          </a:ln>
+          <a:effectLst/>
+        </p:spPr>
+        <p:style>
+          <a:lnRef idx="1">
+            <a:schemeClr val="accent1"/>
+          </a:lnRef>
+          <a:fillRef idx="3">
+            <a:schemeClr val="accent1"/>
+          </a:fillRef>
+          <a:effectRef idx="2">
+            <a:schemeClr val="accent1"/>
+          </a:effectRef>
+          <a:fontRef idx="minor">
+            <a:schemeClr val="lt1"/>
+          </a:fontRef>
+        </p:style>
+        <p:txBody>
+          <a:bodyPr rtlCol="0" anchor="ctr"/>
+          <a:lstStyle/>
+          <a:p>
+            <a:pPr algn="ctr"/>
+          </a:p>
+        </p:txBody>
+      </p:sp>
+      <p:sp>
+        <p:nvSpPr>
+          <p:cNvPr id="3" name="Rectangle 2"/>
+          <p:cNvSpPr/>
+          <p:nvPr/>
+        </p:nvSpPr>
+        <p:spPr>
+          <a:xfrm>
+            <a:off x="0" y="0"/>
+            <a:ext cx="164592" cy="6858000"/>
+          </a:xfrm>
+          <a:prstGeom prst="rect">
+            <a:avLst/>
+          </a:prstGeom>
+          <a:solidFill>
+            <a:srgbClr val="777488"/>
+          </a:solidFill>
+          <a:ln>
+            <a:noFill/>
+          </a:ln>
+          <a:effectLst/>
+        </p:spPr>
+        <p:style>
+          <a:lnRef idx="1">
+            <a:schemeClr val="accent1"/>
+          </a:lnRef>
+          <a:fillRef idx="3">
+            <a:schemeClr val="accent1"/>
+          </a:fillRef>
+          <a:effectRef idx="2">
+            <a:schemeClr val="accent1"/>
+          </a:effectRef>
+          <a:fontRef idx="minor">
+            <a:schemeClr val="lt1"/>
+          </a:fontRef>
+        </p:style>
+        <p:txBody>
+          <a:bodyPr rtlCol="0" anchor="ctr"/>
+          <a:lstStyle/>
+          <a:p>
+            <a:pPr algn="ctr"/>
+          </a:p>
+        </p:txBody>
+      </p:sp>
+      <p:sp>
+        <p:nvSpPr>
+          <p:cNvPr id="4" name="TextBox 3"/>
+          <p:cNvSpPr txBox="1"/>
+          <p:nvPr/>
+        </p:nvSpPr>
+        <p:spPr>
+          <a:xfrm>
+            <a:off x="502920" y="292608"/>
+            <a:ext cx="10424160" cy="365760"/>
+          </a:xfrm>
+          <a:prstGeom prst="rect">
+            <a:avLst/>
+          </a:prstGeom>
+          <a:noFill/>
+        </p:spPr>
+        <p:txBody>
+          <a:bodyPr wrap="square" anchor="t" lIns="45720" rIns="45720" tIns="18288" bIns="18288">
+            <a:spAutoFit/>
+          </a:bodyPr>
+          <a:lstStyle/>
+          <a:p>
+            <a:pPr algn="l">
+              <a:spcBef>
+                <a:spcPts val="0"/>
+              </a:spcBef>
+              <a:spcAft>
+                <a:spcPts val="200"/>
+              </a:spcAft>
+            </a:pPr>
+            <a:r>
+              <a:rPr sz="1200" b="1" i="0">
+                <a:solidFill>
+                  <a:srgbClr val="777488"/>
+                </a:solidFill>
+                <a:latin typeface="Calibri"/>
+              </a:rPr>
+              <a:t>REFERENCES</a:t>
+            </a:r>
+          </a:p>
+        </p:txBody>
+      </p:sp>
+      <p:sp>
+        <p:nvSpPr>
+          <p:cNvPr id="5" name="TextBox 4"/>
+          <p:cNvSpPr txBox="1"/>
+          <p:nvPr/>
+        </p:nvSpPr>
+        <p:spPr>
+          <a:xfrm>
+            <a:off x="502920" y="585216"/>
+            <a:ext cx="10881360" cy="868680"/>
+          </a:xfrm>
+          <a:prstGeom prst="rect">
+            <a:avLst/>
+          </a:prstGeom>
+          <a:noFill/>
+        </p:spPr>
+        <p:txBody>
+          <a:bodyPr wrap="square" anchor="t" lIns="45720" rIns="45720" tIns="18288" bIns="18288">
+            <a:spAutoFit/>
+          </a:bodyPr>
+          <a:lstStyle/>
+          <a:p>
+            <a:pPr algn="l">
+              <a:spcBef>
+                <a:spcPts val="0"/>
+              </a:spcBef>
+              <a:spcAft>
+                <a:spcPts val="0"/>
+              </a:spcAft>
+            </a:pPr>
+            <a:r>
+              <a:rPr sz="2600" b="1" i="0">
+                <a:solidFill>
+                  <a:srgbClr val="1E1B2E"/>
+                </a:solidFill>
+                <a:latin typeface="Calibri"/>
+              </a:rPr>
+              <a:t>App benchmarks &amp; a note on sourcing</a:t>
+            </a:r>
+          </a:p>
+        </p:txBody>
+      </p:sp>
+      <p:sp>
+        <p:nvSpPr>
+          <p:cNvPr id="6" name="Rounded Rectangle 5"/>
+          <p:cNvSpPr/>
+          <p:nvPr/>
+        </p:nvSpPr>
+        <p:spPr>
+          <a:xfrm>
+            <a:off x="11338560" y="310896"/>
+            <a:ext cx="566928" cy="384048"/>
+          </a:xfrm>
+          <a:prstGeom prst="roundRect">
+            <a:avLst/>
+          </a:prstGeom>
+          <a:solidFill>
+            <a:srgbClr val="F4F3FA"/>
+          </a:solidFill>
+          <a:ln>
+            <a:noFill/>
+          </a:ln>
+          <a:effectLst/>
+        </p:spPr>
+        <p:style>
+          <a:lnRef idx="1">
+            <a:schemeClr val="accent1"/>
+          </a:lnRef>
+          <a:fillRef idx="3">
+            <a:schemeClr val="accent1"/>
+          </a:fillRef>
+          <a:effectRef idx="2">
+            <a:schemeClr val="accent1"/>
+          </a:effectRef>
+          <a:fontRef idx="minor">
+            <a:schemeClr val="lt1"/>
+          </a:fontRef>
+        </p:style>
+        <p:txBody>
+          <a:bodyPr rtlCol="0" anchor="ctr"/>
+          <a:lstStyle/>
+          <a:p>
+            <a:pPr algn="ctr"/>
+            <a:r>
+              <a:rPr sz="1200" b="1" i="0">
+                <a:solidFill>
+                  <a:srgbClr val="5B5BE6"/>
+                </a:solidFill>
+                <a:latin typeface="Calibri"/>
+              </a:rPr>
+              <a:t>34</a:t>
+            </a:r>
+          </a:p>
+        </p:txBody>
+      </p:sp>
+      <p:sp>
+        <p:nvSpPr>
+          <p:cNvPr id="7" name="Rectangle 6"/>
+          <p:cNvSpPr/>
+          <p:nvPr/>
+        </p:nvSpPr>
+        <p:spPr>
+          <a:xfrm>
+            <a:off x="502920" y="1335024"/>
+            <a:ext cx="1920240" cy="36576"/>
+          </a:xfrm>
+          <a:prstGeom prst="rect">
+            <a:avLst/>
+          </a:prstGeom>
+          <a:solidFill>
+            <a:srgbClr val="777488"/>
+          </a:solidFill>
+          <a:ln>
+            <a:noFill/>
+          </a:ln>
+          <a:effectLst/>
+        </p:spPr>
+        <p:style>
+          <a:lnRef idx="1">
+            <a:schemeClr val="accent1"/>
+          </a:lnRef>
+          <a:fillRef idx="3">
+            <a:schemeClr val="accent1"/>
+          </a:fillRef>
+          <a:effectRef idx="2">
+            <a:schemeClr val="accent1"/>
+          </a:effectRef>
+          <a:fontRef idx="minor">
+            <a:schemeClr val="lt1"/>
+          </a:fontRef>
+        </p:style>
+        <p:txBody>
+          <a:bodyPr rtlCol="0" anchor="ctr"/>
+          <a:lstStyle/>
+          <a:p>
+            <a:pPr algn="ctr"/>
+          </a:p>
+        </p:txBody>
+      </p:sp>
+      <p:sp>
+        <p:nvSpPr>
+          <p:cNvPr id="8" name="TextBox 7"/>
+          <p:cNvSpPr txBox="1"/>
+          <p:nvPr/>
+        </p:nvSpPr>
+        <p:spPr>
+          <a:xfrm>
+            <a:off x="548640" y="1572768"/>
+            <a:ext cx="11064240" cy="2011680"/>
+          </a:xfrm>
+          <a:prstGeom prst="rect">
+            <a:avLst/>
+          </a:prstGeom>
+          <a:noFill/>
+        </p:spPr>
+        <p:txBody>
+          <a:bodyPr wrap="square" anchor="t" lIns="45720" rIns="45720" tIns="18288" bIns="18288">
+            <a:spAutoFit/>
+          </a:bodyPr>
+          <a:lstStyle/>
+          <a:p>
+            <a:pPr algn="l">
+              <a:spcBef>
+                <a:spcPts val="0"/>
+              </a:spcBef>
+              <a:spcAft>
+                <a:spcPts val="800"/>
+              </a:spcAft>
+            </a:pPr>
+            <a:r>
+              <a:rPr sz="1200" b="1" i="0">
+                <a:solidFill>
+                  <a:srgbClr val="10B7CF"/>
+                </a:solidFill>
+                <a:latin typeface="Calibri"/>
+              </a:rPr>
+              <a:t>SECONDARY — language-app benchmarks (goal/use-case segmentation)</a:t>
+            </a:r>
+          </a:p>
+          <a:p>
+            <a:pPr>
+              <a:spcBef>
+                <a:spcPts val="0"/>
+              </a:spcBef>
+              <a:spcAft>
+                <a:spcPts val="700"/>
+              </a:spcAft>
+            </a:pPr>
+            <a:r>
+              <a:rPr sz="1100" b="1" i="0">
+                <a:solidFill>
+                  <a:srgbClr val="777488"/>
+                </a:solidFill>
+                <a:latin typeface="Calibri"/>
+              </a:rPr>
+              <a:t>9  </a:t>
+            </a:r>
+            <a:r>
+              <a:rPr sz="1150" b="1" i="0">
+                <a:solidFill>
+                  <a:srgbClr val="1E1B2E"/>
+                </a:solidFill>
+                <a:latin typeface="Calibri"/>
+              </a:rPr>
+              <a:t>Babbel — comparison of best language-learning apps (goal-based)</a:t>
+            </a:r>
+          </a:p>
+          <a:p>
+            <a:pPr>
+              <a:spcBef>
+                <a:spcPts val="0"/>
+              </a:spcBef>
+              <a:spcAft>
+                <a:spcPts val="900"/>
+              </a:spcAft>
+            </a:pPr>
+            <a:r>
+              <a:rPr sz="1000" b="0" i="0">
+                <a:solidFill>
+                  <a:srgbClr val="777488"/>
+                </a:solidFill>
+                <a:latin typeface="Calibri"/>
+              </a:rPr>
+              <a:t>      </a:t>
+            </a:r>
+            <a:r>
+              <a:rPr sz="950" b="0" i="0" u="sng">
+                <a:solidFill>
+                  <a:srgbClr val="5B5BE6"/>
+                </a:solidFill>
+                <a:latin typeface="Calibri"/>
+                <a:hlinkClick r:id="rId2"/>
+              </a:rPr>
+              <a:t>https://www.babbel.com/compare-best-language-learning-apps</a:t>
+            </a:r>
+          </a:p>
+          <a:p>
+            <a:pPr>
+              <a:spcBef>
+                <a:spcPts val="0"/>
+              </a:spcBef>
+              <a:spcAft>
+                <a:spcPts val="700"/>
+              </a:spcAft>
+            </a:pPr>
+            <a:r>
+              <a:rPr sz="1100" b="1" i="0">
+                <a:solidFill>
+                  <a:srgbClr val="777488"/>
+                </a:solidFill>
+                <a:latin typeface="Calibri"/>
+              </a:rPr>
+              <a:t>10  </a:t>
+            </a:r>
+            <a:r>
+              <a:rPr sz="1150" b="1" i="0">
+                <a:solidFill>
+                  <a:srgbClr val="1E1B2E"/>
+                </a:solidFill>
+                <a:latin typeface="Calibri"/>
+              </a:rPr>
+              <a:t>Babbel — apps for travelers / digital nomads (use-case framing)</a:t>
+            </a:r>
+          </a:p>
+          <a:p>
+            <a:pPr>
+              <a:spcBef>
+                <a:spcPts val="0"/>
+              </a:spcBef>
+              <a:spcAft>
+                <a:spcPts val="900"/>
+              </a:spcAft>
+            </a:pPr>
+            <a:r>
+              <a:rPr sz="1000" b="0" i="0">
+                <a:solidFill>
+                  <a:srgbClr val="777488"/>
+                </a:solidFill>
+                <a:latin typeface="Calibri"/>
+              </a:rPr>
+              <a:t>      </a:t>
+            </a:r>
+            <a:r>
+              <a:rPr sz="950" b="0" i="0" u="sng">
+                <a:solidFill>
+                  <a:srgbClr val="5B5BE6"/>
+                </a:solidFill>
+                <a:latin typeface="Calibri"/>
+                <a:hlinkClick r:id="rId3"/>
+              </a:rPr>
+              <a:t>https://www.babbel.com/best-language-learning-apps-for-digital-nomads</a:t>
+            </a:r>
+          </a:p>
+        </p:txBody>
+      </p:sp>
+      <p:sp>
+        <p:nvSpPr>
+          <p:cNvPr id="9" name="Rounded Rectangle 8"/>
+          <p:cNvSpPr/>
+          <p:nvPr/>
+        </p:nvSpPr>
+        <p:spPr>
+          <a:xfrm>
+            <a:off x="548640" y="4114800"/>
+            <a:ext cx="11064240" cy="2377440"/>
+          </a:xfrm>
+          <a:prstGeom prst="roundRect">
+            <a:avLst/>
+          </a:prstGeom>
+          <a:solidFill>
+            <a:srgbClr val="FBF1E2"/>
+          </a:solidFill>
+          <a:ln>
+            <a:noFill/>
+          </a:ln>
+          <a:effectLst/>
+        </p:spPr>
+        <p:style>
+          <a:lnRef idx="1">
+            <a:schemeClr val="accent1"/>
+          </a:lnRef>
+          <a:fillRef idx="3">
+            <a:schemeClr val="accent1"/>
+          </a:fillRef>
+          <a:effectRef idx="2">
+            <a:schemeClr val="accent1"/>
+          </a:effectRef>
+          <a:fontRef idx="minor">
+            <a:schemeClr val="lt1"/>
+          </a:fontRef>
+        </p:style>
+        <p:txBody>
+          <a:bodyPr rtlCol="0" anchor="ctr" wrap="square" lIns="182880" rIns="164592" tIns="118872"/>
+          <a:lstStyle/>
+          <a:p>
+            <a:pPr algn="l">
+              <a:spcBef>
+                <a:spcPts val="0"/>
+              </a:spcBef>
+              <a:spcAft>
+                <a:spcPts val="400"/>
+              </a:spcAft>
+            </a:pPr>
+            <a:r>
+              <a:rPr sz="1400" b="1" i="0">
+                <a:solidFill>
+                  <a:srgbClr val="C06A2A"/>
+                </a:solidFill>
+                <a:latin typeface="Calibri"/>
+              </a:rPr>
+              <a:t>Honesty note on sourcing (so you can weigh the claims)</a:t>
+            </a:r>
+          </a:p>
+          <a:p>
+            <a:pPr algn="l">
+              <a:spcBef>
+                <a:spcPts val="0"/>
+              </a:spcBef>
+              <a:spcAft>
+                <a:spcPts val="300"/>
+              </a:spcAft>
+            </a:pPr>
+            <a:r>
+              <a:rPr sz="1350" b="0" i="0">
+                <a:solidFill>
+                  <a:srgbClr val="444455"/>
+                </a:solidFill>
+                <a:latin typeface="Calibri"/>
+              </a:rPr>
+              <a:t>•  The German-framework and exam claims (Mode, sector, situation, counterpart) are grounded in the primary sources 1–8 above. These are the load-bearing research claims and they hold.</a:t>
+            </a:r>
+          </a:p>
+          <a:p>
+            <a:pPr algn="l">
+              <a:spcBef>
+                <a:spcPts val="0"/>
+              </a:spcBef>
+              <a:spcAft>
+                <a:spcPts val="300"/>
+              </a:spcAft>
+            </a:pPr>
+            <a:r>
+              <a:rPr sz="1350" b="0" i="0">
+                <a:solidFill>
+                  <a:srgbClr val="444455"/>
+                </a:solidFill>
+                <a:latin typeface="Calibri"/>
+              </a:rPr>
+              <a:t>•  The structural descriptions of Duolingo, Busuu, Lingoda and Anki / Memrise (slides 2–3) come from general, current product familiarity, not a single cited page each. They are accurate at a high level but are not citation-grade; treat them as informed characterization.</a:t>
+            </a:r>
+          </a:p>
+          <a:p>
+            <a:pPr algn="l">
+              <a:spcBef>
+                <a:spcPts val="0"/>
+              </a:spcBef>
+              <a:spcAft>
+                <a:spcPts val="300"/>
+              </a:spcAft>
+            </a:pPr>
+            <a:r>
+              <a:rPr sz="1350" b="0" i="0">
+                <a:solidFill>
+                  <a:srgbClr val="444455"/>
+                </a:solidFill>
+                <a:latin typeface="Calibri"/>
+              </a:rPr>
+              <a:t>•  Everything about Genauly's current state is verified directly against the codebase, not the web.</a:t>
+            </a:r>
+          </a:p>
+        </p:txBody>
+      </p:sp>
+    </p:spTree>
+  </p:cSld>
+  <p:clrMapOvr>
+    <a:masterClrMapping/>
+  </p:clrMapOvr>
+</p:sld>
+</file>
+
 <file path=ppt/slides/slide4.xml><?xml version="1.0" encoding="utf-8"?>
 <p:sld xmlns:a="http://schemas.openxmlformats.org/drawingml/2006/main" xmlns:p="http://schemas.openxmlformats.org/presentationml/2006/main" xmlns:r="http://schemas.openxmlformats.org/officeDocument/2006/relationships">
   <p:cSld>

</xml_diff>